<commit_message>
Slide accreditatie: titel, consistentie bovenaan, neutrale kleuren
Co-Authored-By: Claude Opus 5.5 <noreply@anthropic.com>
Claude-Session: https://claude.ai/code/session_011t24oNqE5E2i7wh7JuX2xs
</commit_message>
<xml_diff>
--- a/Design/Concepts/kwaliteit-cards/slide/consistent-beoordelen-bewerkbaar.pptx
+++ b/Design/Concepts/kwaliteit-cards/slide/consistent-beoordelen-bewerkbaar.pptx
@@ -3090,18 +3090,57 @@
       <p:grpSpPr/>
       <p:sp>
         <p:nvSpPr>
-          <p:cNvPr id="2" name="Rounded Rectangle 1"/>
+          <p:cNvPr id="2" name="TextBox 1"/>
+          <p:cNvSpPr txBox="1"/>
+          <p:nvPr/>
+        </p:nvSpPr>
+        <p:spPr>
+          <a:xfrm>
+            <a:off x="762000" y="457200"/>
+            <a:ext cx="10668000" cy="609600"/>
+          </a:xfrm>
+          <a:prstGeom prst="rect">
+            <a:avLst/>
+          </a:prstGeom>
+          <a:noFill/>
+        </p:spPr>
+        <p:txBody>
+          <a:bodyPr wrap="square" lIns="0" rIns="0" tIns="0" bIns="0">
+            <a:spAutoFit/>
+          </a:bodyPr>
+          <a:lstStyle/>
+          <a:p>
+            <a:pPr algn="l">
+              <a:lnSpc>
+                <a:spcPct val="100000"/>
+              </a:lnSpc>
+            </a:pPr>
+            <a:r>
+              <a:rPr sz="4000" b="1">
+                <a:solidFill>
+                  <a:srgbClr val="002333"/>
+                </a:solidFill>
+                <a:latin typeface="League Spartan"/>
+              </a:rPr>
+              <a:t>Accreditatie</a:t>
+            </a:r>
+          </a:p>
+        </p:txBody>
+      </p:sp>
+      <p:sp>
+        <p:nvSpPr>
+          <p:cNvPr id="3" name="Rounded Rectangle 2"/>
           <p:cNvSpPr/>
           <p:nvPr/>
         </p:nvSpPr>
         <p:spPr>
           <a:xfrm>
-            <a:off x="762000" y="609600"/>
-            <a:ext cx="7010400" cy="4216400"/>
+            <a:off x="762000" y="1270000"/>
+            <a:ext cx="10668000" cy="2159000"/>
           </a:xfrm>
           <a:prstGeom prst="roundRect">
             <a:avLst>
-              <a:gd name="adj" fmla="val 4819"/>
+              <a:gd name="adj" fmla="val 9411"/>
             </a:avLst>
           </a:prstGeom>
           <a:solidFill>
@@ -3136,14 +3175,14 @@
       </p:sp>
       <p:sp>
         <p:nvSpPr>
-          <p:cNvPr id="3" name="TextBox 2"/>
+          <p:cNvPr id="4" name="TextBox 3"/>
           <p:cNvSpPr txBox="1"/>
           <p:nvPr/>
         </p:nvSpPr>
         <p:spPr>
           <a:xfrm>
-            <a:off x="1168400" y="1016000"/>
-            <a:ext cx="6197600" cy="1016000"/>
+            <a:off x="1168400" y="1574800"/>
+            <a:ext cx="4572000" cy="889000"/>
           </a:xfrm>
           <a:prstGeom prst="rect">
             <a:avLst/>
@@ -3162,7 +3201,7 @@
               </a:lnSpc>
             </a:pPr>
             <a:r>
-              <a:rPr sz="3600" b="1">
+              <a:rPr sz="3200" b="1">
                 <a:solidFill>
                   <a:srgbClr val="FFFFFF"/>
                 </a:solidFill>
@@ -3178,7 +3217,7 @@
               </a:lnSpc>
             </a:pPr>
             <a:r>
-              <a:rPr sz="3600" b="1">
+              <a:rPr sz="3200" b="1">
                 <a:solidFill>
                   <a:srgbClr val="FFFFFF"/>
                 </a:solidFill>
@@ -3191,14 +3230,14 @@
       </p:sp>
       <p:sp>
         <p:nvSpPr>
-          <p:cNvPr id="4" name="TextBox 3"/>
+          <p:cNvPr id="5" name="TextBox 4"/>
           <p:cNvSpPr txBox="1"/>
           <p:nvPr/>
         </p:nvSpPr>
         <p:spPr>
           <a:xfrm>
-            <a:off x="1168400" y="2133600"/>
-            <a:ext cx="6197600" cy="279400"/>
+            <a:off x="1168400" y="2565400"/>
+            <a:ext cx="4445000" cy="533400"/>
           </a:xfrm>
           <a:prstGeom prst="rect">
             <a:avLst/>
@@ -3213,11 +3252,11 @@
           <a:p>
             <a:pPr algn="l">
               <a:lnSpc>
-                <a:spcPct val="115000"/>
+                <a:spcPct val="130000"/>
               </a:lnSpc>
             </a:pPr>
             <a:r>
-              <a:rPr sz="1700" b="0">
+              <a:rPr sz="1600" b="0">
                 <a:solidFill>
                   <a:srgbClr val="A9BCC4"/>
                 </a:solidFill>
@@ -3230,18 +3269,18 @@
       </p:sp>
       <p:sp>
         <p:nvSpPr>
-          <p:cNvPr id="5" name="Rounded Rectangle 4"/>
+          <p:cNvPr id="6" name="Rounded Rectangle 5"/>
           <p:cNvSpPr/>
           <p:nvPr/>
         </p:nvSpPr>
         <p:spPr>
           <a:xfrm>
-            <a:off x="1168400" y="2667000"/>
-            <a:ext cx="6197600" cy="1752600"/>
+            <a:off x="6096000" y="1574800"/>
+            <a:ext cx="4927600" cy="1549400"/>
           </a:xfrm>
           <a:prstGeom prst="roundRect">
             <a:avLst>
-              <a:gd name="adj" fmla="val 5797"/>
+              <a:gd name="adj" fmla="val 6557"/>
             </a:avLst>
           </a:prstGeom>
           <a:solidFill>
@@ -3276,14 +3315,14 @@
       </p:sp>
       <p:sp>
         <p:nvSpPr>
-          <p:cNvPr id="6" name="TextBox 5"/>
+          <p:cNvPr id="7" name="TextBox 6"/>
           <p:cNvSpPr txBox="1"/>
           <p:nvPr/>
         </p:nvSpPr>
         <p:spPr>
           <a:xfrm>
-            <a:off x="1422400" y="2870200"/>
-            <a:ext cx="3556000" cy="254000"/>
+            <a:off x="6350000" y="1727200"/>
+            <a:ext cx="2667000" cy="254000"/>
           </a:xfrm>
           <a:prstGeom prst="rect">
             <a:avLst/>
@@ -3308,20 +3347,20 @@
                 </a:solidFill>
                 <a:latin typeface="Inter"/>
               </a:rPr>
-              <a:t>Voorbeeld, cijfer per docent</a:t>
-            </a:r>
-          </a:p>
-        </p:txBody>
-      </p:sp>
-      <p:sp>
-        <p:nvSpPr>
-          <p:cNvPr id="7" name="TextBox 6"/>
+              <a:t>Voorbeeld per docent</a:t>
+            </a:r>
+          </a:p>
+        </p:txBody>
+      </p:sp>
+      <p:sp>
+        <p:nvSpPr>
+          <p:cNvPr id="8" name="TextBox 7"/>
           <p:cNvSpPr txBox="1"/>
           <p:nvPr/>
         </p:nvSpPr>
         <p:spPr>
           <a:xfrm>
-            <a:off x="5334000" y="2870200"/>
+            <a:off x="9042400" y="1727200"/>
             <a:ext cx="1778000" cy="254000"/>
           </a:xfrm>
           <a:prstGeom prst="rect">
@@ -3354,14 +3393,14 @@
       </p:sp>
       <p:sp>
         <p:nvSpPr>
-          <p:cNvPr id="8" name="TextBox 7"/>
+          <p:cNvPr id="9" name="TextBox 8"/>
           <p:cNvSpPr txBox="1"/>
           <p:nvPr/>
         </p:nvSpPr>
         <p:spPr>
           <a:xfrm>
-            <a:off x="1422400" y="3251200"/>
-            <a:ext cx="1016000" cy="254000"/>
+            <a:off x="6350000" y="2057400"/>
+            <a:ext cx="952500" cy="254000"/>
           </a:xfrm>
           <a:prstGeom prst="rect">
             <a:avLst/>
@@ -3393,14 +3432,14 @@
       </p:sp>
       <p:sp>
         <p:nvSpPr>
-          <p:cNvPr id="9" name="Rounded Rectangle 8"/>
+          <p:cNvPr id="10" name="Rounded Rectangle 9"/>
           <p:cNvSpPr/>
           <p:nvPr/>
         </p:nvSpPr>
         <p:spPr>
           <a:xfrm>
-            <a:off x="2540000" y="3314700"/>
-            <a:ext cx="3810000" cy="127000"/>
+            <a:off x="7366000" y="2120900"/>
+            <a:ext cx="2857500" cy="127000"/>
           </a:xfrm>
           <a:prstGeom prst="roundRect">
             <a:avLst>
@@ -3439,14 +3478,14 @@
       </p:sp>
       <p:sp>
         <p:nvSpPr>
-          <p:cNvPr id="10" name="Rounded Rectangle 9"/>
+          <p:cNvPr id="11" name="Rounded Rectangle 10"/>
           <p:cNvSpPr/>
           <p:nvPr/>
         </p:nvSpPr>
         <p:spPr>
           <a:xfrm>
-            <a:off x="2540000" y="3314700"/>
-            <a:ext cx="2743200" cy="127000"/>
+            <a:off x="7366000" y="2120900"/>
+            <a:ext cx="2057400" cy="127000"/>
           </a:xfrm>
           <a:prstGeom prst="roundRect">
             <a:avLst>
@@ -3454,7 +3493,7 @@
             </a:avLst>
           </a:prstGeom>
           <a:solidFill>
-            <a:srgbClr val="FFFFFF"/>
+            <a:srgbClr val="5B7480"/>
           </a:solidFill>
           <a:ln>
             <a:noFill/>
@@ -3485,14 +3524,14 @@
       </p:sp>
       <p:sp>
         <p:nvSpPr>
-          <p:cNvPr id="11" name="TextBox 10"/>
+          <p:cNvPr id="12" name="TextBox 11"/>
           <p:cNvSpPr txBox="1"/>
           <p:nvPr/>
         </p:nvSpPr>
         <p:spPr>
           <a:xfrm>
-            <a:off x="6540500" y="3251200"/>
-            <a:ext cx="571500" cy="254000"/>
+            <a:off x="10350500" y="2057400"/>
+            <a:ext cx="469900" cy="254000"/>
           </a:xfrm>
           <a:prstGeom prst="rect">
             <a:avLst/>
@@ -3513,7 +3552,7 @@
             <a:r>
               <a:rPr sz="1600" b="1">
                 <a:solidFill>
-                  <a:srgbClr val="FFFFFF"/>
+                  <a:srgbClr val="A9BCC4"/>
                 </a:solidFill>
                 <a:latin typeface="Inter"/>
               </a:rPr>
@@ -3524,14 +3563,14 @@
       </p:sp>
       <p:sp>
         <p:nvSpPr>
-          <p:cNvPr id="12" name="TextBox 11"/>
+          <p:cNvPr id="13" name="TextBox 12"/>
           <p:cNvSpPr txBox="1"/>
           <p:nvPr/>
         </p:nvSpPr>
         <p:spPr>
           <a:xfrm>
-            <a:off x="1422400" y="3606800"/>
-            <a:ext cx="1016000" cy="254000"/>
+            <a:off x="6350000" y="2387600"/>
+            <a:ext cx="952500" cy="254000"/>
           </a:xfrm>
           <a:prstGeom prst="rect">
             <a:avLst/>
@@ -3563,14 +3602,14 @@
       </p:sp>
       <p:sp>
         <p:nvSpPr>
-          <p:cNvPr id="13" name="Rounded Rectangle 12"/>
+          <p:cNvPr id="14" name="Rounded Rectangle 13"/>
           <p:cNvSpPr/>
           <p:nvPr/>
         </p:nvSpPr>
         <p:spPr>
           <a:xfrm>
-            <a:off x="2540000" y="3670300"/>
-            <a:ext cx="3810000" cy="127000"/>
+            <a:off x="7366000" y="2451100"/>
+            <a:ext cx="2857500" cy="127000"/>
           </a:xfrm>
           <a:prstGeom prst="roundRect">
             <a:avLst>
@@ -3609,14 +3648,14 @@
       </p:sp>
       <p:sp>
         <p:nvSpPr>
-          <p:cNvPr id="14" name="Rounded Rectangle 13"/>
+          <p:cNvPr id="15" name="Rounded Rectangle 14"/>
           <p:cNvSpPr/>
           <p:nvPr/>
         </p:nvSpPr>
         <p:spPr>
           <a:xfrm>
-            <a:off x="2540000" y="3670300"/>
-            <a:ext cx="2667000" cy="127000"/>
+            <a:off x="7366000" y="2451100"/>
+            <a:ext cx="2000250" cy="127000"/>
           </a:xfrm>
           <a:prstGeom prst="roundRect">
             <a:avLst>
@@ -3624,7 +3663,7 @@
             </a:avLst>
           </a:prstGeom>
           <a:solidFill>
-            <a:srgbClr val="FFFFFF"/>
+            <a:srgbClr val="5B7480"/>
           </a:solidFill>
           <a:ln>
             <a:noFill/>
@@ -3655,14 +3694,14 @@
       </p:sp>
       <p:sp>
         <p:nvSpPr>
-          <p:cNvPr id="15" name="TextBox 14"/>
+          <p:cNvPr id="16" name="TextBox 15"/>
           <p:cNvSpPr txBox="1"/>
           <p:nvPr/>
         </p:nvSpPr>
         <p:spPr>
           <a:xfrm>
-            <a:off x="6540500" y="3606800"/>
-            <a:ext cx="571500" cy="254000"/>
+            <a:off x="10350500" y="2387600"/>
+            <a:ext cx="469900" cy="254000"/>
           </a:xfrm>
           <a:prstGeom prst="rect">
             <a:avLst/>
@@ -3683,7 +3722,7 @@
             <a:r>
               <a:rPr sz="1600" b="1">
                 <a:solidFill>
-                  <a:srgbClr val="FFFFFF"/>
+                  <a:srgbClr val="A9BCC4"/>
                 </a:solidFill>
                 <a:latin typeface="Inter"/>
               </a:rPr>
@@ -3694,14 +3733,14 @@
       </p:sp>
       <p:sp>
         <p:nvSpPr>
-          <p:cNvPr id="16" name="TextBox 15"/>
+          <p:cNvPr id="17" name="TextBox 16"/>
           <p:cNvSpPr txBox="1"/>
           <p:nvPr/>
         </p:nvSpPr>
         <p:spPr>
           <a:xfrm>
-            <a:off x="1422400" y="3962400"/>
-            <a:ext cx="1016000" cy="254000"/>
+            <a:off x="6350000" y="2717800"/>
+            <a:ext cx="952500" cy="254000"/>
           </a:xfrm>
           <a:prstGeom prst="rect">
             <a:avLst/>
@@ -3733,14 +3772,14 @@
       </p:sp>
       <p:sp>
         <p:nvSpPr>
-          <p:cNvPr id="17" name="Rounded Rectangle 16"/>
+          <p:cNvPr id="18" name="Rounded Rectangle 17"/>
           <p:cNvSpPr/>
           <p:nvPr/>
         </p:nvSpPr>
         <p:spPr>
           <a:xfrm>
-            <a:off x="2540000" y="4025900"/>
-            <a:ext cx="3810000" cy="127000"/>
+            <a:off x="7366000" y="2781300"/>
+            <a:ext cx="2857500" cy="127000"/>
           </a:xfrm>
           <a:prstGeom prst="roundRect">
             <a:avLst>
@@ -3779,14 +3818,14 @@
       </p:sp>
       <p:sp>
         <p:nvSpPr>
-          <p:cNvPr id="18" name="Rounded Rectangle 17"/>
+          <p:cNvPr id="19" name="Rounded Rectangle 18"/>
           <p:cNvSpPr/>
           <p:nvPr/>
         </p:nvSpPr>
         <p:spPr>
           <a:xfrm>
-            <a:off x="2540000" y="4025900"/>
-            <a:ext cx="2133600" cy="127000"/>
+            <a:off x="7366000" y="2781300"/>
+            <a:ext cx="1600200" cy="127000"/>
           </a:xfrm>
           <a:prstGeom prst="roundRect">
             <a:avLst>
@@ -3794,7 +3833,7 @@
             </a:avLst>
           </a:prstGeom>
           <a:solidFill>
-            <a:srgbClr val="E07B00"/>
+            <a:srgbClr val="FFFFFF"/>
           </a:solidFill>
           <a:ln>
             <a:noFill/>
@@ -3825,14 +3864,14 @@
       </p:sp>
       <p:sp>
         <p:nvSpPr>
-          <p:cNvPr id="19" name="TextBox 18"/>
+          <p:cNvPr id="20" name="TextBox 19"/>
           <p:cNvSpPr txBox="1"/>
           <p:nvPr/>
         </p:nvSpPr>
         <p:spPr>
           <a:xfrm>
-            <a:off x="6540500" y="3962400"/>
-            <a:ext cx="571500" cy="254000"/>
+            <a:off x="10350500" y="2717800"/>
+            <a:ext cx="469900" cy="254000"/>
           </a:xfrm>
           <a:prstGeom prst="rect">
             <a:avLst/>
@@ -3853,7 +3892,7 @@
             <a:r>
               <a:rPr sz="1600" b="1">
                 <a:solidFill>
-                  <a:srgbClr val="E07B00"/>
+                  <a:srgbClr val="FFFFFF"/>
                 </a:solidFill>
                 <a:latin typeface="Inter"/>
               </a:rPr>
@@ -3864,20 +3903,20 @@
       </p:sp>
       <p:sp>
         <p:nvSpPr>
-          <p:cNvPr id="20" name="Rectangle 19"/>
+          <p:cNvPr id="21" name="Rectangle 20"/>
           <p:cNvSpPr/>
           <p:nvPr/>
         </p:nvSpPr>
         <p:spPr>
           <a:xfrm>
-            <a:off x="5235575" y="3175000"/>
-            <a:ext cx="19050" cy="1066800"/>
+            <a:off x="9385300" y="2006600"/>
+            <a:ext cx="19050" cy="1016000"/>
           </a:xfrm>
           <a:prstGeom prst="rect">
             <a:avLst/>
           </a:prstGeom>
           <a:solidFill>
-            <a:srgbClr val="8FA9B4"/>
+            <a:srgbClr val="A9BCC4"/>
           </a:solidFill>
           <a:ln>
             <a:noFill/>
@@ -3908,18 +3947,18 @@
       </p:sp>
       <p:sp>
         <p:nvSpPr>
-          <p:cNvPr id="21" name="Rounded Rectangle 20"/>
+          <p:cNvPr id="22" name="Rounded Rectangle 21"/>
           <p:cNvSpPr/>
           <p:nvPr/>
         </p:nvSpPr>
         <p:spPr>
           <a:xfrm>
-            <a:off x="7975600" y="609600"/>
-            <a:ext cx="3454400" cy="2159000"/>
+            <a:off x="762000" y="3632200"/>
+            <a:ext cx="5715000" cy="1498600"/>
           </a:xfrm>
           <a:prstGeom prst="roundRect">
             <a:avLst>
-              <a:gd name="adj" fmla="val 7058"/>
+              <a:gd name="adj" fmla="val 10169"/>
             </a:avLst>
           </a:prstGeom>
           <a:solidFill>
@@ -3954,18 +3993,18 @@
       </p:sp>
       <p:sp>
         <p:nvSpPr>
-          <p:cNvPr id="22" name="Rounded Rectangle 21"/>
+          <p:cNvPr id="23" name="Rounded Rectangle 22"/>
           <p:cNvSpPr/>
           <p:nvPr/>
         </p:nvSpPr>
         <p:spPr>
           <a:xfrm>
-            <a:off x="7988300" y="622300"/>
-            <a:ext cx="3429000" cy="2133600"/>
+            <a:off x="774700" y="3644900"/>
+            <a:ext cx="5689600" cy="1473200"/>
           </a:xfrm>
           <a:prstGeom prst="roundRect">
             <a:avLst>
-              <a:gd name="adj" fmla="val 6547"/>
+              <a:gd name="adj" fmla="val 9482"/>
             </a:avLst>
           </a:prstGeom>
           <a:solidFill>
@@ -4000,14 +4039,14 @@
       </p:sp>
       <p:sp>
         <p:nvSpPr>
-          <p:cNvPr id="23" name="TextBox 22"/>
+          <p:cNvPr id="24" name="TextBox 23"/>
           <p:cNvSpPr txBox="1"/>
           <p:nvPr/>
         </p:nvSpPr>
         <p:spPr>
           <a:xfrm>
-            <a:off x="8280400" y="863600"/>
-            <a:ext cx="2844800" cy="635000"/>
+            <a:off x="1066800" y="3886200"/>
+            <a:ext cx="5080000" cy="355600"/>
           </a:xfrm>
           <a:prstGeom prst="rect">
             <a:avLst/>
@@ -4032,37 +4071,21 @@
                 </a:solidFill>
                 <a:latin typeface="League Spartan"/>
               </a:rPr>
-              <a:t>Elk cijfer is</a:t>
-            </a:r>
-          </a:p>
-          <a:p>
-            <a:pPr algn="l">
-              <a:lnSpc>
-                <a:spcPct val="105000"/>
-              </a:lnSpc>
-            </a:pPr>
-            <a:r>
-              <a:rPr sz="2400" b="1">
-                <a:solidFill>
-                  <a:srgbClr val="002333"/>
-                </a:solidFill>
-                <a:latin typeface="League Spartan"/>
-              </a:rPr>
-              <a:t>navolgbaar</a:t>
-            </a:r>
-          </a:p>
-        </p:txBody>
-      </p:sp>
-      <p:sp>
-        <p:nvSpPr>
-          <p:cNvPr id="24" name="TextBox 23"/>
+              <a:t>Elk cijfer is navolgbaar</a:t>
+            </a:r>
+          </a:p>
+        </p:txBody>
+      </p:sp>
+      <p:sp>
+        <p:nvSpPr>
+          <p:cNvPr id="25" name="TextBox 24"/>
           <p:cNvSpPr txBox="1"/>
           <p:nvPr/>
         </p:nvSpPr>
         <p:spPr>
           <a:xfrm>
-            <a:off x="8280400" y="1600200"/>
-            <a:ext cx="2844800" cy="508000"/>
+            <a:off x="1066800" y="4292600"/>
+            <a:ext cx="5080000" cy="254000"/>
           </a:xfrm>
           <a:prstGeom prst="rect">
             <a:avLst/>
@@ -4077,7 +4100,7 @@
           <a:p>
             <a:pPr algn="l">
               <a:lnSpc>
-                <a:spcPct val="125000"/>
+                <a:spcPct val="115000"/>
               </a:lnSpc>
             </a:pPr>
             <a:r>
@@ -4094,14 +4117,14 @@
       </p:sp>
       <p:sp>
         <p:nvSpPr>
-          <p:cNvPr id="25" name="Rounded Rectangle 24"/>
+          <p:cNvPr id="26" name="Rounded Rectangle 25"/>
           <p:cNvSpPr/>
           <p:nvPr/>
         </p:nvSpPr>
         <p:spPr>
           <a:xfrm>
-            <a:off x="8280400" y="2209800"/>
-            <a:ext cx="2159000" cy="330200"/>
+            <a:off x="1066800" y="4622800"/>
+            <a:ext cx="2159000" cy="304800"/>
           </a:xfrm>
           <a:prstGeom prst="roundRect">
             <a:avLst>
@@ -4140,13 +4163,13 @@
       </p:sp>
       <p:sp>
         <p:nvSpPr>
-          <p:cNvPr id="26" name="TextBox 25"/>
+          <p:cNvPr id="27" name="TextBox 26"/>
           <p:cNvSpPr txBox="1"/>
           <p:nvPr/>
         </p:nvSpPr>
         <p:spPr>
           <a:xfrm>
-            <a:off x="8280400" y="2266950"/>
+            <a:off x="1066800" y="4660900"/>
             <a:ext cx="2159000" cy="228600"/>
           </a:xfrm>
           <a:prstGeom prst="rect">
@@ -4179,18 +4202,18 @@
       </p:sp>
       <p:sp>
         <p:nvSpPr>
-          <p:cNvPr id="27" name="Rounded Rectangle 26"/>
+          <p:cNvPr id="28" name="Rounded Rectangle 27"/>
           <p:cNvSpPr/>
           <p:nvPr/>
         </p:nvSpPr>
         <p:spPr>
           <a:xfrm>
-            <a:off x="7975600" y="2971800"/>
-            <a:ext cx="3454400" cy="1854200"/>
+            <a:off x="6680200" y="3632200"/>
+            <a:ext cx="4749800" cy="1498600"/>
           </a:xfrm>
           <a:prstGeom prst="roundRect">
             <a:avLst>
-              <a:gd name="adj" fmla="val 8219"/>
+              <a:gd name="adj" fmla="val 10169"/>
             </a:avLst>
           </a:prstGeom>
           <a:solidFill>
@@ -4225,14 +4248,14 @@
       </p:sp>
       <p:sp>
         <p:nvSpPr>
-          <p:cNvPr id="28" name="TextBox 27"/>
+          <p:cNvPr id="29" name="TextBox 28"/>
           <p:cNvSpPr txBox="1"/>
           <p:nvPr/>
         </p:nvSpPr>
         <p:spPr>
           <a:xfrm>
-            <a:off x="8280400" y="3276600"/>
-            <a:ext cx="2844800" cy="584200"/>
+            <a:off x="6985000" y="3886200"/>
+            <a:ext cx="4140200" cy="584200"/>
           </a:xfrm>
           <a:prstGeom prst="rect">
             <a:avLst/>
@@ -4257,7 +4280,7 @@
                 </a:solidFill>
                 <a:latin typeface="League Spartan"/>
               </a:rPr>
-              <a:t>De examencommissie</a:t>
+              <a:t>De examencommissie borgt</a:t>
             </a:r>
           </a:p>
           <a:p>
@@ -4273,21 +4296,21 @@
                 </a:solidFill>
                 <a:latin typeface="League Spartan"/>
               </a:rPr>
-              <a:t>borgt de kwaliteit</a:t>
-            </a:r>
-          </a:p>
-        </p:txBody>
-      </p:sp>
-      <p:sp>
-        <p:nvSpPr>
-          <p:cNvPr id="29" name="TextBox 28"/>
+              <a:t>de kwaliteit</a:t>
+            </a:r>
+          </a:p>
+        </p:txBody>
+      </p:sp>
+      <p:sp>
+        <p:nvSpPr>
+          <p:cNvPr id="30" name="TextBox 29"/>
           <p:cNvSpPr txBox="1"/>
           <p:nvPr/>
         </p:nvSpPr>
         <p:spPr>
           <a:xfrm>
-            <a:off x="8280400" y="3987800"/>
-            <a:ext cx="2844800" cy="508000"/>
+            <a:off x="6985000" y="4572000"/>
+            <a:ext cx="4140200" cy="254000"/>
           </a:xfrm>
           <a:prstGeom prst="rect">
             <a:avLst/>
@@ -4302,7 +4325,7 @@
           <a:p>
             <a:pPr algn="l">
               <a:lnSpc>
-                <a:spcPct val="125000"/>
+                <a:spcPct val="115000"/>
               </a:lnSpc>
             </a:pPr>
             <a:r>
@@ -4319,22 +4342,20 @@
       </p:sp>
       <p:sp>
         <p:nvSpPr>
-          <p:cNvPr id="30" name="Rounded Rectangle 29"/>
+          <p:cNvPr id="31" name="Rectangle 30"/>
           <p:cNvSpPr/>
           <p:nvPr/>
         </p:nvSpPr>
         <p:spPr>
           <a:xfrm>
-            <a:off x="762000" y="5029200"/>
-            <a:ext cx="10668000" cy="1270000"/>
-          </a:xfrm>
-          <a:prstGeom prst="roundRect">
-            <a:avLst>
-              <a:gd name="adj" fmla="val 8000"/>
-            </a:avLst>
+            <a:off x="762000" y="5334000"/>
+            <a:ext cx="25400" cy="863600"/>
+          </a:xfrm>
+          <a:prstGeom prst="rect">
+            <a:avLst/>
           </a:prstGeom>
           <a:solidFill>
-            <a:srgbClr val="F3F7F8"/>
+            <a:srgbClr val="CDD9DE"/>
           </a:solidFill>
           <a:ln>
             <a:noFill/>
@@ -4365,58 +4386,14 @@
       </p:sp>
       <p:sp>
         <p:nvSpPr>
-          <p:cNvPr id="31" name="Rectangle 30"/>
-          <p:cNvSpPr/>
-          <p:nvPr/>
-        </p:nvSpPr>
-        <p:spPr>
-          <a:xfrm>
-            <a:off x="762000" y="5029200"/>
-            <a:ext cx="63500" cy="1270000"/>
-          </a:xfrm>
-          <a:prstGeom prst="rect">
-            <a:avLst/>
-          </a:prstGeom>
-          <a:solidFill>
-            <a:srgbClr val="002333"/>
-          </a:solidFill>
-          <a:ln>
-            <a:noFill/>
-          </a:ln>
-          <a:effectLst/>
-        </p:spPr>
-        <p:style>
-          <a:lnRef idx="1">
-            <a:schemeClr val="accent1"/>
-          </a:lnRef>
-          <a:fillRef idx="3">
-            <a:schemeClr val="accent1"/>
-          </a:fillRef>
-          <a:effectRef idx="2">
-            <a:schemeClr val="accent1"/>
-          </a:effectRef>
-          <a:fontRef idx="minor">
-            <a:schemeClr val="lt1"/>
-          </a:fontRef>
-        </p:style>
-        <p:txBody>
-          <a:bodyPr rtlCol="0" anchor="ctr"/>
-          <a:lstStyle/>
-          <a:p>
-            <a:pPr algn="ctr"/>
-          </a:p>
-        </p:txBody>
-      </p:sp>
-      <p:sp>
-        <p:nvSpPr>
           <p:cNvPr id="32" name="TextBox 31"/>
           <p:cNvSpPr txBox="1"/>
           <p:nvPr/>
         </p:nvSpPr>
         <p:spPr>
           <a:xfrm>
-            <a:off x="1117600" y="5257800"/>
-            <a:ext cx="10033000" cy="889000"/>
+            <a:off x="1016000" y="5334000"/>
+            <a:ext cx="10414000" cy="863600"/>
           </a:xfrm>
           <a:prstGeom prst="rect">
             <a:avLst/>
@@ -4431,11 +4408,11 @@
           <a:p>
             <a:pPr algn="l">
               <a:lnSpc>
-                <a:spcPct val="135000"/>
+                <a:spcPct val="140000"/>
               </a:lnSpc>
             </a:pPr>
             <a:r>
-              <a:rPr sz="1700" b="1">
+              <a:rPr sz="1600" b="0">
                 <a:solidFill>
                   <a:srgbClr val="002333"/>
                 </a:solidFill>

</xml_diff>